<commit_message>
docs(handouts): update IgniSense presentation deck
</commit_message>
<xml_diff>
--- a/docs/handouts/IgniSense-Deck.pptx
+++ b/docs/handouts/IgniSense-Deck.pptx
@@ -728,7 +728,7 @@
           <a:lstStyle/>
           <a:p>
             <a:r>
-              <a:t>This is the evidence that it isn't reading the injected fault. An audience member selects a sealed case; the fault is chosen inside the simulation worker, and the interface never learns what is in it. The monitor has to identify it, and then the answer is revealed.</a:t>
+              <a:t>This is the proof it isn't reading the injected fault. A visitor picks a sealed card; the fault is chosen inside the worker, and the page never learns what's on it. The monitor has to name it, and then we reveal.</a:t>
             </a:r>
           </a:p>
         </p:txBody>
@@ -1078,7 +1078,7 @@
           <a:lstStyle/>
           <a:p>
             <a:r>
-              <a:t>Invite the audience to choose a fault for you to inject, or to select a blind-test case.</a:t>
+              <a:t>Invite them to pick a card, or to name a fault for you to inject.</a:t>
             </a:r>
           </a:p>
         </p:txBody>
@@ -1358,7 +1358,7 @@
           <a:lstStyle/>
           <a:p>
             <a:r>
-              <a:t>Every gauge carries a Twin marker: the white tick is what a healthy engine would read right now, at the same speed, load and ambient. The delta turns coloured once it leaves the noise. The tachometer is a car-style dial. Click any number and you get the equation.</a:t>
+              <a:t>Every gauge carries a ghost: the white tick is what a healthy engine would read right now, at the same speed, load and ambient. The delta turns coloured once it leaves the noise. The tachometer is a car-style dial. Click any number and you get the equation.</a:t>
             </a:r>
           </a:p>
         </p:txBody>
@@ -5811,7 +5811,7 @@
                 </a:solidFill>
                 <a:latin typeface="Consolas"/>
               </a:rPr>
-              <a:t>10 · CALCULATIONS</a:t>
+              <a:t>10 · SHOW THE MATH</a:t>
             </a:r>
           </a:p>
         </p:txBody>
@@ -6479,7 +6479,7 @@
                 </a:solidFill>
                 <a:latin typeface="Consolas"/>
               </a:rPr>
-              <a:t>11 · BLIND TEST</a:t>
+              <a:t>11 · BLIND CHALLENGE</a:t>
             </a:r>
           </a:p>
         </p:txBody>
@@ -6649,7 +6649,7 @@
                 </a:solidFill>
                 <a:latin typeface="Segoe UI"/>
               </a:rPr>
-              <a:t>Test it blind.</a:t>
+              <a:t>Don't trust us. Pick a card.</a:t>
             </a:r>
           </a:p>
         </p:txBody>
@@ -6735,7 +6735,7 @@
                 </a:solidFill>
                 <a:latin typeface="Segoe UI"/>
               </a:rPr>
-              <a:t>Nine sealed fault cases, shuffled inside the simulation.</a:t>
+              <a:t>Nine sealed fault cards, shuffled inside the simulation.</a:t>
             </a:r>
           </a:p>
         </p:txBody>
@@ -6821,7 +6821,7 @@
                 </a:solidFill>
                 <a:latin typeface="Segoe UI"/>
               </a:rPr>
-              <a:t>The interface never sees what is in the case.</a:t>
+              <a:t>The page never sees what is on the card.</a:t>
             </a:r>
           </a:p>
         </p:txBody>
@@ -11195,7 +11195,7 @@
                 </a:solidFill>
                 <a:latin typeface="Segoe UI"/>
               </a:rPr>
-              <a:t>Choose a fault.</a:t>
+              <a:t>Pick a card.</a:t>
             </a:r>
           </a:p>
           <a:p>
@@ -11214,7 +11214,7 @@
                 </a:solidFill>
                 <a:latin typeface="Segoe UI"/>
               </a:rPr>
-              <a:t>See it diagnosed.</a:t>
+              <a:t>We'll prove it.</a:t>
             </a:r>
           </a:p>
         </p:txBody>
@@ -13791,7 +13791,7 @@
         <p:spPr>
           <a:xfrm>
             <a:off x="822959" y="4604004"/>
-            <a:ext cx="4023360" cy="544068"/>
+            <a:ext cx="4023360" cy="272034"/>
           </a:xfrm>
           <a:prstGeom prst="rect">
             <a:avLst/>
@@ -13819,7 +13819,7 @@
                 </a:solidFill>
                 <a:latin typeface="Segoe UI"/>
               </a:rPr>
-              <a:t>Click any part for its sensors and its calculation.</a:t>
+              <a:t>Click any part for its sensors and its math.</a:t>
             </a:r>
           </a:p>
         </p:txBody>
@@ -14125,7 +14125,7 @@
                 </a:solidFill>
                 <a:latin typeface="Segoe UI"/>
               </a:rPr>
-              <a:t>Every gauge has a reference</a:t>
+              <a:t>Every gauge has a ghost</a:t>
             </a:r>
           </a:p>
         </p:txBody>

</xml_diff>